<commit_message>
Resolved conflict between local code and GitBook docs
</commit_message>
<xml_diff>
--- a/PharmacyPrescriptionManagerPresentation.pptx
+++ b/PharmacyPrescriptionManagerPresentation.pptx
@@ -6006,8 +6006,8 @@
         </p:nvSpPr>
         <p:spPr>
           <a:xfrm>
-            <a:off x="365760" y="4703996"/>
-            <a:ext cx="8412480" cy="347472"/>
+            <a:off x="365760" y="4517136"/>
+            <a:ext cx="8412480" cy="626364"/>
           </a:xfrm>
           <a:prstGeom prst="rect">
             <a:avLst/>
@@ -6027,10 +6027,10 @@
       </p:sp>
       <p:sp>
         <p:nvSpPr>
-          <p:cNvPr id="26" name="Text 3">
+          <p:cNvPr id="29" name="Text 3">
             <a:extLst>
               <a:ext uri="{FF2B5EF4-FFF2-40B4-BE49-F238E27FC236}">
-                <a16:creationId xmlns:a16="http://schemas.microsoft.com/office/drawing/2014/main" id="{B9E8C50B-96FC-8D6B-5C25-10BFB03FD99D}"/>
+                <a16:creationId xmlns:a16="http://schemas.microsoft.com/office/drawing/2014/main" id="{E05E06F1-6169-DBDB-FBC3-624DC6BAE584}"/>
               </a:ext>
             </a:extLst>
           </p:cNvPr>
@@ -6039,7 +6039,7 @@
         </p:nvSpPr>
         <p:spPr>
           <a:xfrm>
-            <a:off x="502920" y="4703996"/>
+            <a:off x="548640" y="4641656"/>
             <a:ext cx="1097280" cy="347472"/>
           </a:xfrm>
           <a:prstGeom prst="rect">
@@ -6052,9 +6052,6 @@
           <a:bodyPr wrap="square" rtlCol="0" anchor="ctr"/>
           <a:lstStyle/>
           <a:p>
-            <a:pPr marL="0" indent="0">
-              <a:buNone/>
-            </a:pPr>
             <a:r>
               <a:rPr lang="en-US" sz="1000" b="1" dirty="0">
                 <a:solidFill>
@@ -6066,16 +6063,56 @@
               </a:rPr>
               <a:t>Live URL:</a:t>
             </a:r>
+          </a:p>
+          <a:p>
+            <a:r>
+              <a:rPr lang="en-US" sz="1000" b="1" dirty="0">
+                <a:solidFill>
+                  <a:srgbClr val="02C39A"/>
+                </a:solidFill>
+                <a:latin typeface="Calibri" pitchFamily="34" charset="0"/>
+                <a:ea typeface="Calibri" pitchFamily="34" charset="-122"/>
+                <a:cs typeface="Calibri" pitchFamily="34" charset="-120"/>
+              </a:rPr>
+              <a:t>GitHub URL:</a:t>
+            </a:r>
+          </a:p>
+          <a:p>
+            <a:pPr marL="0" indent="0">
+              <a:buNone/>
+            </a:pPr>
+            <a:r>
+              <a:rPr lang="en-US" sz="1000" b="1" dirty="0" err="1">
+                <a:solidFill>
+                  <a:srgbClr val="02C39A"/>
+                </a:solidFill>
+                <a:latin typeface="Calibri" pitchFamily="34" charset="0"/>
+                <a:ea typeface="Calibri" pitchFamily="34" charset="-122"/>
+                <a:cs typeface="Calibri" pitchFamily="34" charset="-120"/>
+              </a:rPr>
+              <a:t>GitBook</a:t>
+            </a:r>
+            <a:r>
+              <a:rPr lang="en-US" sz="1000" b="1" dirty="0">
+                <a:solidFill>
+                  <a:srgbClr val="02C39A"/>
+                </a:solidFill>
+                <a:latin typeface="Calibri" pitchFamily="34" charset="0"/>
+                <a:ea typeface="Calibri" pitchFamily="34" charset="-122"/>
+                <a:cs typeface="Calibri" pitchFamily="34" charset="-120"/>
+              </a:rPr>
+              <a:t> URL:</a:t>
+            </a:r>
             <a:endParaRPr lang="en-US" sz="1000" dirty="0"/>
           </a:p>
         </p:txBody>
       </p:sp>
       <p:sp>
         <p:nvSpPr>
-          <p:cNvPr id="27" name="Text 4">
+          <p:cNvPr id="31" name="Text 4">
             <a:extLst>
               <a:ext uri="{FF2B5EF4-FFF2-40B4-BE49-F238E27FC236}">
-                <a16:creationId xmlns:a16="http://schemas.microsoft.com/office/drawing/2014/main" id="{20999317-C09E-4B1D-304B-82F030B65C54}"/>
+                <a16:creationId xmlns:a16="http://schemas.microsoft.com/office/drawing/2014/main" id="{C3E35A99-66B0-0693-654E-01F9FAB715E1}"/>
               </a:ext>
             </a:extLst>
           </p:cNvPr>
@@ -6084,7 +6121,7 @@
         </p:nvSpPr>
         <p:spPr>
           <a:xfrm>
-            <a:off x="1051560" y="4692645"/>
+            <a:off x="1291590" y="4636008"/>
             <a:ext cx="7040880" cy="347472"/>
           </a:xfrm>
           <a:prstGeom prst="rect">
@@ -6097,9 +6134,6 @@
           <a:bodyPr wrap="square" rtlCol="0" anchor="ctr"/>
           <a:lstStyle/>
           <a:p>
-            <a:pPr marL="0" indent="0">
-              <a:buNone/>
-            </a:pPr>
             <a:r>
               <a:rPr lang="en-US" sz="1100" dirty="0" err="1">
                 <a:solidFill>
@@ -6111,82 +6145,63 @@
               </a:rPr>
               <a:t>pharmacyprescriptionmanager-production.up.railway.app</a:t>
             </a:r>
+            <a:endParaRPr lang="en-US" sz="1100" dirty="0">
+              <a:solidFill>
+                <a:srgbClr val="FFFFFF"/>
+              </a:solidFill>
+              <a:latin typeface="Calibri" pitchFamily="34" charset="0"/>
+              <a:ea typeface="Calibri" pitchFamily="34" charset="-122"/>
+              <a:cs typeface="Calibri" pitchFamily="34" charset="-120"/>
+            </a:endParaRPr>
+          </a:p>
+          <a:p>
+            <a:r>
+              <a:rPr lang="en-US" sz="1100" dirty="0" err="1">
+                <a:solidFill>
+                  <a:schemeClr val="bg1"/>
+                </a:solidFill>
+                <a:latin typeface="Calibri" pitchFamily="34" charset="0"/>
+                <a:ea typeface="Calibri" pitchFamily="34" charset="-122"/>
+                <a:cs typeface="Calibri" pitchFamily="34" charset="-120"/>
+              </a:rPr>
+              <a:t>github.com</a:t>
+            </a:r>
+            <a:r>
+              <a:rPr lang="en-US" sz="1100" dirty="0">
+                <a:solidFill>
+                  <a:schemeClr val="bg1"/>
+                </a:solidFill>
+                <a:latin typeface="Calibri" pitchFamily="34" charset="0"/>
+                <a:ea typeface="Calibri" pitchFamily="34" charset="-122"/>
+                <a:cs typeface="Calibri" pitchFamily="34" charset="-120"/>
+              </a:rPr>
+              <a:t>/ashastri7/</a:t>
+            </a:r>
+            <a:r>
+              <a:rPr lang="en-US" sz="1100" dirty="0" err="1">
+                <a:solidFill>
+                  <a:schemeClr val="bg1"/>
+                </a:solidFill>
+                <a:latin typeface="Calibri" pitchFamily="34" charset="0"/>
+                <a:ea typeface="Calibri" pitchFamily="34" charset="-122"/>
+                <a:cs typeface="Calibri" pitchFamily="34" charset="-120"/>
+              </a:rPr>
+              <a:t>Pharmacy_Prescription_Manager</a:t>
+            </a:r>
             <a:endParaRPr lang="en-US" sz="1100" dirty="0"/>
           </a:p>
-        </p:txBody>
-      </p:sp>
-      <p:sp>
-        <p:nvSpPr>
-          <p:cNvPr id="30" name="Text 3">
-            <a:extLst>
-              <a:ext uri="{FF2B5EF4-FFF2-40B4-BE49-F238E27FC236}">
-                <a16:creationId xmlns:a16="http://schemas.microsoft.com/office/drawing/2014/main" id="{9ACE1BF0-0890-CFF5-F4DC-1ABAF7E37CCD}"/>
-              </a:ext>
-            </a:extLst>
-          </p:cNvPr>
-          <p:cNvSpPr/>
-          <p:nvPr/>
-        </p:nvSpPr>
-        <p:spPr>
-          <a:xfrm>
-            <a:off x="4480560" y="4695469"/>
-            <a:ext cx="1097280" cy="347472"/>
-          </a:xfrm>
-          <a:prstGeom prst="rect">
-            <a:avLst/>
-          </a:prstGeom>
-          <a:noFill/>
-          <a:ln/>
-        </p:spPr>
-        <p:txBody>
-          <a:bodyPr wrap="square" rtlCol="0" anchor="ctr"/>
-          <a:lstStyle/>
-          <a:p>
-            <a:pPr marL="0" indent="0">
-              <a:buNone/>
-            </a:pPr>
-            <a:r>
-              <a:rPr lang="en-US" sz="1000" b="1" dirty="0">
-                <a:solidFill>
-                  <a:srgbClr val="02C39A"/>
-                </a:solidFill>
-                <a:latin typeface="Calibri" pitchFamily="34" charset="0"/>
-                <a:ea typeface="Calibri" pitchFamily="34" charset="-122"/>
-                <a:cs typeface="Calibri" pitchFamily="34" charset="-120"/>
-              </a:rPr>
-              <a:t>GitHub URL:</a:t>
-            </a:r>
-            <a:endParaRPr lang="en-US" sz="1000" dirty="0"/>
-          </a:p>
-        </p:txBody>
-      </p:sp>
-      <p:sp>
-        <p:nvSpPr>
-          <p:cNvPr id="35" name="Text 4">
-            <a:extLst>
-              <a:ext uri="{FF2B5EF4-FFF2-40B4-BE49-F238E27FC236}">
-                <a16:creationId xmlns:a16="http://schemas.microsoft.com/office/drawing/2014/main" id="{05995A7E-9A75-A78D-B9C4-D006DEC4705D}"/>
-              </a:ext>
-            </a:extLst>
-          </p:cNvPr>
-          <p:cNvSpPr/>
-          <p:nvPr/>
-        </p:nvSpPr>
-        <p:spPr>
-          <a:xfrm>
-            <a:off x="5223510" y="4689821"/>
-            <a:ext cx="7040880" cy="347472"/>
-          </a:xfrm>
-          <a:prstGeom prst="rect">
-            <a:avLst/>
-          </a:prstGeom>
-          <a:noFill/>
-          <a:ln/>
-        </p:spPr>
-        <p:txBody>
-          <a:bodyPr wrap="square" rtlCol="0" anchor="ctr"/>
-          <a:lstStyle/>
-          <a:p>
+          <a:p>
+            <a:r>
+              <a:rPr lang="en-US" sz="1100" dirty="0">
+                <a:solidFill>
+                  <a:schemeClr val="bg1"/>
+                </a:solidFill>
+                <a:latin typeface="Calibri" pitchFamily="34" charset="0"/>
+                <a:ea typeface="Calibri" pitchFamily="34" charset="-122"/>
+                <a:cs typeface="Calibri" pitchFamily="34" charset="-120"/>
+              </a:rPr>
+              <a:t>https://</a:t>
+            </a:r>
             <a:r>
               <a:rPr lang="en-US" sz="1100" dirty="0" err="1">
                 <a:solidFill>
@@ -6196,7 +6211,7 @@
                 <a:ea typeface="Calibri" pitchFamily="34" charset="-122"/>
                 <a:cs typeface="Calibri" pitchFamily="34" charset="-120"/>
               </a:rPr>
-              <a:t>github.com</a:t>
+              <a:t>umassd.gitbook.io</a:t>
             </a:r>
             <a:r>
               <a:rPr lang="en-US" sz="1100" dirty="0">
@@ -6207,7 +6222,7 @@
                 <a:ea typeface="Calibri" pitchFamily="34" charset="-122"/>
                 <a:cs typeface="Calibri" pitchFamily="34" charset="-120"/>
               </a:rPr>
-              <a:t>/ashastri7/</a:t>
+              <a:t>/</a:t>
             </a:r>
             <a:r>
               <a:rPr lang="en-US" sz="1100" dirty="0" err="1">
@@ -6218,7 +6233,18 @@
                 <a:ea typeface="Calibri" pitchFamily="34" charset="-122"/>
                 <a:cs typeface="Calibri" pitchFamily="34" charset="-120"/>
               </a:rPr>
-              <a:t>Pharmacy_Prescription_Manager</a:t>
+              <a:t>umassd</a:t>
+            </a:r>
+            <a:r>
+              <a:rPr lang="en-US" sz="1100" dirty="0">
+                <a:solidFill>
+                  <a:schemeClr val="bg1"/>
+                </a:solidFill>
+                <a:latin typeface="Calibri" pitchFamily="34" charset="0"/>
+                <a:ea typeface="Calibri" pitchFamily="34" charset="-122"/>
+                <a:cs typeface="Calibri" pitchFamily="34" charset="-120"/>
+              </a:rPr>
+              <a:t>-docs</a:t>
             </a:r>
             <a:endParaRPr lang="en-US" sz="1100" dirty="0">
               <a:solidFill>

</xml_diff>